<commit_message>
Security step 3: isolate provider replies in a least-privilege agent
Fixes the review finding that the agent reading untrusted provider replies
could also approve and send:
- New reply_agent holds only check_inbox and record_reply. tracker_agent no
  longer sees reply text.
- check_inbox returns reply text as untrusted_body with a warning not to
  follow it.
- record_reply acts only on a real, unprocessed reply and its own task (the
  server decides which task), changes status only on tasks already sent, and
  clips recorded facts.

Regression tests check from the network file that no agent that reads
replies can approve or send, and that an injected reply claiming customer
approval changes nothing. README and deck updated: 14 agents, 27 coded
tools, all four review findings fixed for the demo.

Co-Authored-By: Claude Opus 5.5 <noreply@anthropic.com>
</commit_message>
<xml_diff>
--- a/House_Move_Agent.pptx
+++ b/House_Move_Agent.pptx
@@ -122,25 +122,25 @@
   <p:extLst>
     <p:ext uri="{521415D9-36F7-43E2-AB2F-B90AF26B5E84}">
       <p14:sectionLst xmlns:p14="http://schemas.microsoft.com/office/powerpoint/2010/main">
-        <p14:section name="Opening" id="{6923acea-2c84-9b14-5539-e0bb9da4e5e1}">
+        <p14:section name="Opening" id="{c41c606d-0ff6-89f4-a067-79e2d1377021}">
           <p14:sldIdLst>
             <p14:sldId id="256"/>
           </p14:sldIdLst>
         </p14:section>
-        <p14:section name="Problem and solution" id="{4c2a3e03-4446-291e-a762-1aa9d5089aa4}">
+        <p14:section name="Problem and solution" id="{fb938f56-d9ff-d97c-7831-46d0da6e472a}">
           <p14:sldIdLst>
             <p14:sldId id="257"/>
             <p14:sldId id="258"/>
             <p14:sldId id="259"/>
           </p14:sldIdLst>
         </p14:section>
-        <p14:section name="The two AI moments" id="{c944c1eb-4848-9a0c-6e48-df6403e2c2b3}">
+        <p14:section name="The two AI moments" id="{7f368d55-436b-bb54-9686-9bcc98278901}">
           <p14:sldIdLst>
             <p14:sldId id="260"/>
             <p14:sldId id="261"/>
           </p14:sldIdLst>
         </p14:section>
-        <p14:section name="How it works" id="{a9c8074b-71c7-25a6-5cf6-4badad5de0db}">
+        <p14:section name="How it works" id="{8fbcc18c-b759-de5d-d168-d9374675a540}">
           <p14:sldIdLst>
             <p14:sldId id="262"/>
             <p14:sldId id="263"/>
@@ -150,7 +150,7 @@
             <p14:sldId id="267"/>
           </p14:sldIdLst>
         </p14:section>
-        <p14:section name="Results and next steps" id="{f50098be-5d4a-a6bf-8b38-6a2020ad43b7}">
+        <p14:section name="Results and next steps" id="{c35f549e-c087-50b4-0819-7ca90f8aaf6f}">
           <p14:sldIdLst>
             <p14:sldId id="268"/>
             <p14:sldId id="269"/>
@@ -914,7 +914,7 @@
           <a:p>
             <a:r>
               <a:rPr lang="en-US" dirty="0"/>
-              <a:t>Each control is enforced in code and replayed as an attack in test_session_security.py: forged approved state is discarded, another customer's record will not open, tampered tokens are refused. Approvals, imports and deletions need a one-time code the customer types; middleware records their real message and the tool checks it, so an LLM or an injected provider reply cannot approve. Next fix: move reply handling into an agent with no send tools.</a:t>
+              <a:t>Each control is enforced in code and replayed as an attack in test_session_security.py: forged approved state is discarded, another customer's record will not open, tampered tokens are refused. Approvals, imports and deletions need a one-time code the customer types; middleware records their real message and the tool checks it, so an LLM or an injected provider reply cannot approve. Provider replies are read only by reply_agent, which has no approve or send tools.</a:t>
             </a:r>
             <a:endParaRPr lang="en-US" dirty="0"/>
           </a:p>
@@ -2146,7 +2146,7 @@
           <a:p>
             <a:r>
               <a:rPr lang="en-US" dirty="0"/>
-              <a:t>13 LLM agents and 26 coded tools. The coordinator is the only agent the customer talks to. Pipeline agents are called in order; the four specialists use AAOSA. Every deadline, fee, send and date change runs through a coded tool, not the LLM.</a:t>
+              <a:t>14 LLM agents and 27 coded tools. The coordinator is the only agent the customer talks to. Pipeline agents are called in order; the four specialists use AAOSA. Every deadline, fee, send and date change runs through a coded tool, not the LLM.</a:t>
             </a:r>
             <a:endParaRPr lang="en-US" dirty="0"/>
           </a:p>
@@ -2927,7 +2927,7 @@
                   <a:schemeClr val="bg2"/>
                 </a:solidFill>
               </a:rPr>
-              <a:t>Multi-agent assistant built on Neuro SAN  ·  13 agents  ·  synthetic data</a:t>
+              <a:t>Multi-agent assistant built on Neuro SAN  ·  14 agents  ·  synthetic data</a:t>
             </a:r>
             <a:endParaRPr lang="en-US" sz="1400" dirty="0"/>
           </a:p>
@@ -5417,7 +5417,7 @@
                 <a:ea typeface="Cambria" pitchFamily="34" charset="-122"/>
                 <a:cs typeface="Cambria" pitchFamily="34" charset="-120"/>
               </a:rPr>
-              <a:t>13</a:t>
+              <a:t>14</a:t>
             </a:r>
             <a:endParaRPr lang="en-US" sz="5400" dirty="0"/>
           </a:p>
@@ -5514,7 +5514,7 @@
                 <a:ea typeface="Cambria" pitchFamily="34" charset="-122"/>
                 <a:cs typeface="Cambria" pitchFamily="34" charset="-120"/>
               </a:rPr>
-              <a:t>26</a:t>
+              <a:t>27</a:t>
             </a:r>
             <a:endParaRPr lang="en-US" sz="5400" dirty="0"/>
           </a:p>
@@ -5708,7 +5708,7 @@
                 <a:ea typeface="Cambria" pitchFamily="34" charset="-122"/>
                 <a:cs typeface="Cambria" pitchFamily="34" charset="-120"/>
               </a:rPr>
-              <a:t>77</a:t>
+              <a:t>82</a:t>
             </a:r>
             <a:endParaRPr lang="en-US" sz="5400" dirty="0"/>
           </a:p>
@@ -11419,7 +11419,7 @@
                   <a:schemeClr val="tx2"/>
                 </a:solidFill>
               </a:rPr>
-              <a:t>13 agents on Neuro SAN, 26 coded tools</a:t>
+              <a:t>14 agents on Neuro SAN, 27 coded tools</a:t>
             </a:r>
             <a:endParaRPr lang="en-US" sz="3400" dirty="0"/>
           </a:p>
@@ -11848,7 +11848,7 @@
                   <a:schemeClr val="tx1"/>
                 </a:solidFill>
               </a:rPr>
-              <a:t>comms (drafts) · tracker (approve, send, replan, replies)</a:t>
+              <a:t>comms (drafts) · tracker (approval codes, send, replan) · reply agent</a:t>
             </a:r>
             <a:endParaRPr lang="en-US" sz="1800" dirty="0"/>
           </a:p>
@@ -12048,7 +12048,7 @@
                 <a:gridCol w="4114800"/>
                 <a:gridCol w="4572000"/>
               </a:tblGrid>
-              <a:tr h="329184">
+              <a:tr h="301752">
                 <a:tc>
                   <a:txBody>
                     <a:bodyPr/>
@@ -12161,7 +12161,7 @@
                   </a:tcPr>
                 </a:tc>
               </a:tr>
-              <a:tr h="329184">
+              <a:tr h="301752">
                 <a:tc>
                   <a:txBody>
                     <a:bodyPr/>
@@ -12274,7 +12274,7 @@
                   </a:tcPr>
                 </a:tc>
               </a:tr>
-              <a:tr h="329184">
+              <a:tr h="301752">
                 <a:tc>
                   <a:txBody>
                     <a:bodyPr/>
@@ -12387,7 +12387,7 @@
                   </a:tcPr>
                 </a:tc>
               </a:tr>
-              <a:tr h="329184">
+              <a:tr h="301752">
                 <a:tc>
                   <a:txBody>
                     <a:bodyPr/>
@@ -12500,7 +12500,7 @@
                   </a:tcPr>
                 </a:tc>
               </a:tr>
-              <a:tr h="329184">
+              <a:tr h="301752">
                 <a:tc>
                   <a:txBody>
                     <a:bodyPr/>
@@ -12613,7 +12613,7 @@
                   </a:tcPr>
                 </a:tc>
               </a:tr>
-              <a:tr h="329184">
+              <a:tr h="301752">
                 <a:tc>
                   <a:txBody>
                     <a:bodyPr/>
@@ -12726,7 +12726,7 @@
                   </a:tcPr>
                 </a:tc>
               </a:tr>
-              <a:tr h="329184">
+              <a:tr h="301752">
                 <a:tc>
                   <a:txBody>
                     <a:bodyPr/>
@@ -12839,7 +12839,7 @@
                   </a:tcPr>
                 </a:tc>
               </a:tr>
-              <a:tr h="329184">
+              <a:tr h="301752">
                 <a:tc>
                   <a:txBody>
                     <a:bodyPr/>
@@ -12952,7 +12952,7 @@
                   </a:tcPr>
                 </a:tc>
               </a:tr>
-              <a:tr h="329184">
+              <a:tr h="301752">
                 <a:tc>
                   <a:txBody>
                     <a:bodyPr/>
@@ -13065,7 +13065,7 @@
                   </a:tcPr>
                 </a:tc>
               </a:tr>
-              <a:tr h="329184">
+              <a:tr h="301752">
                 <a:tc>
                   <a:txBody>
                     <a:bodyPr/>
@@ -13178,7 +13178,7 @@
                   </a:tcPr>
                 </a:tc>
               </a:tr>
-              <a:tr h="329184">
+              <a:tr h="301752">
                 <a:tc>
                   <a:txBody>
                     <a:bodyPr/>
@@ -13291,7 +13291,7 @@
                   </a:tcPr>
                 </a:tc>
               </a:tr>
-              <a:tr h="329184">
+              <a:tr h="301752">
                 <a:tc>
                   <a:txBody>
                     <a:bodyPr/>
@@ -13404,7 +13404,7 @@
                   </a:tcPr>
                 </a:tc>
               </a:tr>
-              <a:tr h="329184">
+              <a:tr h="301752">
                 <a:tc>
                   <a:txBody>
                     <a:bodyPr/>
@@ -13517,7 +13517,7 @@
                   </a:tcPr>
                 </a:tc>
               </a:tr>
-              <a:tr h="329184">
+              <a:tr h="301752">
                 <a:tc>
                   <a:txBody>
                     <a:bodyPr/>
@@ -13569,7 +13569,7 @@
                             <a:schemeClr val="tx1"/>
                           </a:solidFill>
                         </a:rPr>
-                        <a:t>AI moment 2: approve, send, replan, replies</a:t>
+                        <a:t>AI moment 2: approval codes, send, replan, audit</a:t>
                       </a:r>
                       <a:endParaRPr lang="en-US" sz="1400" dirty="0"/>
                     </a:p>
@@ -13606,7 +13606,7 @@
                             <a:schemeClr val="accent5"/>
                           </a:solidFill>
                         </a:rPr>
-                        <a:t>approve_drafts, send_notification, plan_corrections</a:t>
+                        <a:t>request_approval, confirm_with_code, send_notification</a:t>
                       </a:r>
                       <a:endParaRPr lang="en-US" sz="1400" dirty="0"/>
                     </a:p>
@@ -13626,6 +13626,119 @@
                     </a:lnB>
                     <a:solidFill>
                       <a:schemeClr val="bg2"/>
+                    </a:solidFill>
+                  </a:tcPr>
+                </a:tc>
+              </a:tr>
+              <a:tr h="301752">
+                <a:tc>
+                  <a:txBody>
+                    <a:bodyPr/>
+                    <a:lstStyle/>
+                    <a:p>
+                      <a:pPr indent="0" marL="0">
+                        <a:buNone/>
+                      </a:pPr>
+                      <a:r>
+                        <a:rPr lang="en-US" sz="1400" b="1" dirty="0">
+                          <a:solidFill>
+                            <a:schemeClr val="tx2"/>
+                          </a:solidFill>
+                        </a:rPr>
+                        <a:t>reply_agent</a:t>
+                      </a:r>
+                      <a:endParaRPr lang="en-US" sz="1400" dirty="0"/>
+                    </a:p>
+                  </a:txBody>
+                  <a:tcPr marL="73152" marR="73152" marT="0" marB="0" anchor="ctr">
+                    <a:lnL w="0" cap="flat" cmpd="sng" algn="ctr">
+                      <a:noFill/>
+                    </a:lnL>
+                    <a:lnR w="0" cap="flat" cmpd="sng" algn="ctr">
+                      <a:noFill/>
+                    </a:lnR>
+                    <a:lnT w="0" cap="flat" cmpd="sng" algn="ctr">
+                      <a:noFill/>
+                    </a:lnT>
+                    <a:lnB w="0" cap="flat" cmpd="sng" algn="ctr">
+                      <a:noFill/>
+                    </a:lnB>
+                    <a:solidFill>
+                      <a:schemeClr val="bg1"/>
+                    </a:solidFill>
+                  </a:tcPr>
+                </a:tc>
+                <a:tc>
+                  <a:txBody>
+                    <a:bodyPr/>
+                    <a:lstStyle/>
+                    <a:p>
+                      <a:pPr indent="0" marL="0">
+                        <a:buNone/>
+                      </a:pPr>
+                      <a:r>
+                        <a:rPr lang="en-US" sz="1400" dirty="0">
+                          <a:solidFill>
+                            <a:schemeClr val="tx1"/>
+                          </a:solidFill>
+                        </a:rPr>
+                        <a:t>Reads provider replies; no approve or send tools</a:t>
+                      </a:r>
+                      <a:endParaRPr lang="en-US" sz="1400" dirty="0"/>
+                    </a:p>
+                  </a:txBody>
+                  <a:tcPr marL="73152" marR="73152" marT="0" marB="0" anchor="ctr">
+                    <a:lnL w="0" cap="flat" cmpd="sng" algn="ctr">
+                      <a:noFill/>
+                    </a:lnL>
+                    <a:lnR w="0" cap="flat" cmpd="sng" algn="ctr">
+                      <a:noFill/>
+                    </a:lnR>
+                    <a:lnT w="0" cap="flat" cmpd="sng" algn="ctr">
+                      <a:noFill/>
+                    </a:lnT>
+                    <a:lnB w="0" cap="flat" cmpd="sng" algn="ctr">
+                      <a:noFill/>
+                    </a:lnB>
+                    <a:solidFill>
+                      <a:schemeClr val="bg1"/>
+                    </a:solidFill>
+                  </a:tcPr>
+                </a:tc>
+                <a:tc>
+                  <a:txBody>
+                    <a:bodyPr/>
+                    <a:lstStyle/>
+                    <a:p>
+                      <a:pPr indent="0" marL="0">
+                        <a:buNone/>
+                      </a:pPr>
+                      <a:r>
+                        <a:rPr lang="en-US" sz="1400" dirty="0">
+                          <a:solidFill>
+                            <a:schemeClr val="accent5"/>
+                          </a:solidFill>
+                        </a:rPr>
+                        <a:t>check_inbox, record_reply</a:t>
+                      </a:r>
+                      <a:endParaRPr lang="en-US" sz="1400" dirty="0"/>
+                    </a:p>
+                  </a:txBody>
+                  <a:tcPr marL="73152" marR="73152" marT="0" marB="0" anchor="ctr">
+                    <a:lnL w="0" cap="flat" cmpd="sng" algn="ctr">
+                      <a:noFill/>
+                    </a:lnL>
+                    <a:lnR w="0" cap="flat" cmpd="sng" algn="ctr">
+                      <a:noFill/>
+                    </a:lnR>
+                    <a:lnT w="0" cap="flat" cmpd="sng" algn="ctr">
+                      <a:noFill/>
+                    </a:lnT>
+                    <a:lnB w="0" cap="flat" cmpd="sng" algn="ctr">
+                      <a:noFill/>
+                    </a:lnB>
+                    <a:solidFill>
+                      <a:schemeClr val="bg1"/>
                     </a:solidFill>
                   </a:tcPr>
                 </a:tc>

</xml_diff>

<commit_message>
Fix plan integrity issues from the second review
- Task IDs come from the rule's place in the rules file, and a rebuild carries progress over by obligation, so
  a fact that changes can no longer move one task's status, sends or replies onto another. Existing plans keep
  their IDs, and a dropped task that was already sent is reported.
- With no exchange date, home insurance is dated today rather than at completion.
- Completion and exchange dates are checked when a case is created and when the plan is built.
- A move within one council gives one council tax task.

Co-Authored-By: Claude Opus 5.5 <noreply@anthropic.com>
</commit_message>
<xml_diff>
--- a/House_Move_Agent.pptx
+++ b/House_Move_Agent.pptx
@@ -123,25 +123,25 @@
   <p:extLst>
     <p:ext uri="{521415D9-36F7-43E2-AB2F-B90AF26B5E84}">
       <p14:sectionLst xmlns:p14="http://schemas.microsoft.com/office/powerpoint/2010/main">
-        <p14:section name="Opening" id="{c9f73559-486e-cb1d-5eb8-e72a273e22c9}">
+        <p14:section name="Opening" id="{8db38e7f-526c-96f4-7757-19f0f49f99a2}">
           <p14:sldIdLst>
             <p14:sldId id="256"/>
           </p14:sldIdLst>
         </p14:section>
-        <p14:section name="Problem and solution" id="{06f2789e-1c5f-001a-3509-e3f351f4bd9c}">
+        <p14:section name="Problem and solution" id="{0046e609-b4aa-da1f-3932-a7057d752608}">
           <p14:sldIdLst>
             <p14:sldId id="257"/>
             <p14:sldId id="258"/>
             <p14:sldId id="259"/>
           </p14:sldIdLst>
         </p14:section>
-        <p14:section name="The two AI moments" id="{59aa4c55-cd12-2416-f8ed-a3cdd3423c95}">
+        <p14:section name="The two AI moments" id="{f2b1bec3-601a-6c21-c00a-5804ad3d240e}">
           <p14:sldIdLst>
             <p14:sldId id="260"/>
             <p14:sldId id="261"/>
           </p14:sldIdLst>
         </p14:section>
-        <p14:section name="How it works" id="{60ea59f4-40d7-b79c-bcf4-22b0a42a604d}">
+        <p14:section name="How it works" id="{443fa03d-4f26-31b7-fc44-0a91d62ff491}">
           <p14:sldIdLst>
             <p14:sldId id="262"/>
             <p14:sldId id="263"/>
@@ -152,7 +152,7 @@
             <p14:sldId id="268"/>
           </p14:sldIdLst>
         </p14:section>
-        <p14:section name="Results and next steps" id="{83a8bb52-d35b-1eec-4a11-c82ae9ea0263}">
+        <p14:section name="Results and next steps" id="{f894f490-7d69-0820-6a49-8452639c8a40}">
           <p14:sldIdLst>
             <p14:sldId id="269"/>
             <p14:sldId id="270"/>
@@ -7411,7 +7411,7 @@
                 <a:ea typeface="Cambria" pitchFamily="34" charset="-122"/>
                 <a:cs typeface="Cambria" pitchFamily="34" charset="-120"/>
               </a:rPr>
-              <a:t>23</a:t>
+              <a:t>24</a:t>
             </a:r>
             <a:endParaRPr lang="en-US" sz="5400" dirty="0"/>
           </a:p>
@@ -7447,7 +7447,7 @@
                   <a:schemeClr val="tx1"/>
                 </a:solidFill>
               </a:rPr>
-              <a:t>rules, 20 verified</a:t>
+              <a:t>rules, 21 verified</a:t>
             </a:r>
             <a:endParaRPr lang="en-US" sz="1700" dirty="0"/>
           </a:p>
@@ -7508,7 +7508,7 @@
                 <a:ea typeface="Cambria" pitchFamily="34" charset="-122"/>
                 <a:cs typeface="Cambria" pitchFamily="34" charset="-120"/>
               </a:rPr>
-              <a:t>95</a:t>
+              <a:t>103</a:t>
             </a:r>
             <a:endParaRPr lang="en-US" sz="5400" dirty="0"/>
           </a:p>
@@ -12786,7 +12786,7 @@
                   <a:schemeClr val="tx1"/>
                 </a:solidFill>
               </a:rPr>
-              <a:t>Which obligations apply (23 rules, each with a source)</a:t>
+              <a:t>Which obligations apply (24 rules, each with a source)</a:t>
             </a:r>
             <a:endParaRPr lang="en-US" sz="1600" dirty="0"/>
           </a:p>

</xml_diff>

<commit_message>
Fix standalone journey and data protection issues from the third review
- Personal details come only from the portal's new "Your details" page, checked field by field and held
  encrypted until create_case moves them into the case's vault; details sent through the chat are discarded.
- A missing or blank detail, or an address with no street, is a gap, so the letter goes to the customer.
- Every portal form post must come from the portal; uploads never imported are deleted after a day.
- Scripted replies reach only the demo customer, from the task's own provider, and only for letters that
  reached the organisation; customer packs show as "Ready for you to send".
- Keys live in an owner-only folder away from the data (existing keys are moved), the database is owner-only,
  statement rows are encrypted (old rows on open), the plan stores no filled-in letters, and SQLite
  overwrites deleted data.

Co-Authored-By: Claude Opus 5.5 <noreply@anthropic.com>
</commit_message>
<xml_diff>
--- a/House_Move_Agent.pptx
+++ b/House_Move_Agent.pptx
@@ -123,25 +123,25 @@
   <p:extLst>
     <p:ext uri="{521415D9-36F7-43E2-AB2F-B90AF26B5E84}">
       <p14:sectionLst xmlns:p14="http://schemas.microsoft.com/office/powerpoint/2010/main">
-        <p14:section name="Opening" id="{8db38e7f-526c-96f4-7757-19f0f49f99a2}">
+        <p14:section name="Opening" id="{32af6478-886a-f9b4-2793-5194e9a143c8}">
           <p14:sldIdLst>
             <p14:sldId id="256"/>
           </p14:sldIdLst>
         </p14:section>
-        <p14:section name="Problem and solution" id="{0046e609-b4aa-da1f-3932-a7057d752608}">
+        <p14:section name="Problem and solution" id="{eb6c9fe1-3a8f-71fe-4187-5caa8428923b}">
           <p14:sldIdLst>
             <p14:sldId id="257"/>
             <p14:sldId id="258"/>
             <p14:sldId id="259"/>
           </p14:sldIdLst>
         </p14:section>
-        <p14:section name="The two AI moments" id="{f2b1bec3-601a-6c21-c00a-5804ad3d240e}">
+        <p14:section name="The two AI moments" id="{02e568eb-836b-c4e3-d3c5-fe8da0230644}">
           <p14:sldIdLst>
             <p14:sldId id="260"/>
             <p14:sldId id="261"/>
           </p14:sldIdLst>
         </p14:section>
-        <p14:section name="How it works" id="{443fa03d-4f26-31b7-fc44-0a91d62ff491}">
+        <p14:section name="How it works" id="{b991e49f-39d1-fa60-4fdc-34d4c1e7b43d}">
           <p14:sldIdLst>
             <p14:sldId id="262"/>
             <p14:sldId id="263"/>
@@ -152,7 +152,7 @@
             <p14:sldId id="268"/>
           </p14:sldIdLst>
         </p14:section>
-        <p14:section name="Results and next steps" id="{f894f490-7d69-0820-6a49-8452639c8a40}">
+        <p14:section name="Results and next steps" id="{a50f64f1-e823-4dd3-7e0a-d5857ca682e0}">
           <p14:sldIdLst>
             <p14:sldId id="269"/>
             <p14:sldId id="270"/>
@@ -3748,7 +3748,7 @@
                   <a:schemeClr val="tx1"/>
                 </a:solidFill>
               </a:rPr>
-              <a:t>Plan state and personal details encrypted; delete on request</a:t>
+              <a:t>Details, statements and plans encrypted; keys kept apart</a:t>
             </a:r>
             <a:endParaRPr lang="en-US" sz="1400" dirty="0"/>
           </a:p>
@@ -7508,7 +7508,7 @@
                 <a:ea typeface="Cambria" pitchFamily="34" charset="-122"/>
                 <a:cs typeface="Cambria" pitchFamily="34" charset="-120"/>
               </a:rPr>
-              <a:t>103</a:t>
+              <a:t>115</a:t>
             </a:r>
             <a:endParaRPr lang="en-US" sz="5400" dirty="0"/>
           </a:p>

</xml_diff>

<commit_message>
#18: Update the deck to the current app and its evaluations
Co-Authored-By: Claude Opus 5.5 <noreply@anthropic.com>
</commit_message>
<xml_diff>
--- a/House_Move_Agent.pptx
+++ b/House_Move_Agent.pptx
@@ -16,8 +16,10 @@
     <p:sldId id="264" r:id="rId10"/>
     <p:sldId id="265" r:id="rId11"/>
     <p:sldId id="266" r:id="rId12"/>
+    <p:sldId id="273" r:id="rId24"/>
     <p:sldId id="267" r:id="rId13"/>
     <p:sldId id="268" r:id="rId14"/>
+    <p:sldId id="274" r:id="rId25"/>
     <p:sldId id="269" r:id="rId15"/>
     <p:sldId id="270" r:id="rId16"/>
     <p:sldId id="271" r:id="rId17"/>
@@ -148,12 +150,14 @@
             <p14:sldId id="264"/>
             <p14:sldId id="265"/>
             <p14:sldId id="266"/>
+            <p14:sldId id="273"/>
             <p14:sldId id="267"/>
             <p14:sldId id="268"/>
           </p14:sldIdLst>
         </p14:section>
         <p14:section name="Results and next steps" id="{a50f64f1-e823-4dd3-7e0a-d5857ca682e0}">
           <p14:sldIdLst>
+            <p14:sldId id="274"/>
             <p14:sldId id="269"/>
             <p14:sldId id="270"/>
             <p14:sldId id="271"/>
@@ -915,10 +919,8 @@
           <a:lstStyle/>
           <a:p>
             <a:r>
-              <a:rPr lang="en-US" dirty="0"/>
-              <a:t>Each control is enforced in code and replayed as an attack in test_session_security.py: forged approved state is discarded, another customer's record will not open, tampered tokens are refused. Approvals, imports and deletions need a one-time code the customer types; middleware records their real message and the tool checks it, so an LLM or an injected provider reply cannot approve. Provider replies are read only by reply_agent, which has no approve or send tools. On the portal, approval comes from the customer's own signed-in browser, so no LLM is involved; it is tied to the exact wording they read.</a:t>
-            </a:r>
-            <a:endParaRPr lang="en-US" dirty="0"/>
+              <a:t>Each control is enforced in code and replayed as an attack in test_session_security.py: forged approved state is discarded, another customer's record will not open, tampered tokens are refused, and a customer ID the LLM passes to a tool cannot read another customer's payments (the evaluations caught that one). Approvals, imports and deletions in the chat need a one-time code the customer types; middleware records their real message and the tool checks it, so an LLM or an injected provider reply cannot approve. Provider replies are read only by reply_agent, which has no approve or send tools. In the app, approval comes from the customer's own signed-in browser, so no LLM is involved; it is tied to the exact wording they read.</a:t>
+            </a:r>
           </a:p>
         </p:txBody>
       </p:sp>
@@ -1003,10 +1005,8 @@
           <a:lstStyle/>
           <a:p>
             <a:r>
-              <a:rPr lang="en-US" dirty="0"/>
-              <a:t>The status page reads the same server-side case the agents use, under the same ownership rules. Approving there takes the owner's lock (shared with the agent server through a file lock) and records the fingerprint of the draft the customer opened, which send_notification checks. Codes are never shown here.</a:t>
-            </a:r>
-            <a:endParaRPr lang="en-US" dirty="0"/>
+              <a:t>The House Move app reads the same server-side case the agents use, under the same ownership rules. The next step is worked out from the real case, so it always matches what has happened. Approve all approves every routine letter the customer has been shown, each with the fingerprint of its wording; legal requirements follow one at a time. Change asks the assistant to rewrite one letter, which then needs approving again; Skip asks for confirmation, and a legal requirement needs an explicit one. Codes are never shown here.</a:t>
+            </a:r>
           </a:p>
         </p:txBody>
       </p:sp>
@@ -1179,10 +1179,8 @@
           <a:lstStyle/>
           <a:p>
             <a:r>
-              <a:rPr lang="en-US" dirty="0"/>
-              <a:t>Real public data, no API keys. GP practices and phone numbers come live from the NHS; schools from the Department for Education's register, rebuilt daily if needed.</a:t>
-            </a:r>
-            <a:endParaRPr lang="en-US" dirty="0"/>
+              <a:t>Water and sewerage come live from Ofwat's appointed area maps (April 2024, Open Government Licence) at the postcode's coordinates, so Chelmsford is Essex &amp; Suffolk Water with Anglian sewerage, and Bristol is Bristol Water with Wessex. If that service is down, a checked table answers. GP practices and phone numbers come live from the NHS; schools from the Department for Education's register.</a:t>
+            </a:r>
           </a:p>
         </p:txBody>
       </p:sp>
@@ -1267,10 +1265,8 @@
           <a:lstStyle/>
           <a:p>
             <a:r>
-              <a:rPr lang="en-US" dirty="0"/>
-              <a:t>Every number is from the repository: agents and tools in the network file, rules in obligations_rules.json, tests from pytest.</a:t>
-            </a:r>
-            <a:endParaRPr lang="en-US" dirty="0"/>
+              <a:t>Every number is from the repository: agents and tools in the network file, rules in obligations_rules.json, unit tests from pytest, and the live AI evaluation runs in tests/fixtures/hackathon/house_move.</a:t>
+            </a:r>
           </a:p>
         </p:txBody>
       </p:sp>
@@ -1531,10 +1527,8 @@
           <a:lstStyle/>
           <a:p>
             <a:r>
-              <a:rPr lang="en-US" dirty="0"/>
-              <a:t>Demo order: discovery, live council lookup, the dated plan with local contacts, drafts and approval (in the chat or on the My move page), the date slip, a provider reply, the audit trail.</a:t>
-            </a:r>
-            <a:endParaRPr lang="en-US" dirty="0"/>
+              <a:t>Demo order: sign in on the House Move app, discovery, the dated plan with local contacts, Approve all (or review one by one: approve, change, skip), send, open a Ready for you to send pack, the date slip, a provider reply, the audit trail. Show the agent graph in nsflow alongside.</a:t>
+            </a:r>
           </a:p>
         </p:txBody>
       </p:sp>
@@ -1567,6 +1561,146 @@
         <p14:creationId xmlns:p14="http://schemas.microsoft.com/office/powerpoint/2010/main" val="1024086991"/>
       </p:ext>
     </p:extLst>
+  </p:cSld>
+  <p:clrMapOvr>
+    <a:masterClrMapping/>
+  </p:clrMapOvr>
+</p:notes>
+</file>
+
+<file path=ppt/notesSlides/notesSlide18.xml><?xml version="1.0" encoding="utf-8"?>
+<p:notes xmlns:a="http://schemas.openxmlformats.org/drawingml/2006/main" xmlns:p="http://schemas.openxmlformats.org/presentationml/2006/main" xmlns:r="http://schemas.openxmlformats.org/officeDocument/2006/relationships">
+  <p:cSld>
+    <p:spTree>
+      <p:nvGrpSpPr>
+        <p:cNvPr id="1" name=""/>
+        <p:cNvGrpSpPr/>
+        <p:nvPr/>
+      </p:nvGrpSpPr>
+      <p:grpSpPr>
+        <a:xfrm>
+          <a:off x="0" y="0"/>
+          <a:ext cx="0" cy="0"/>
+          <a:chOff x="0" y="0"/>
+          <a:chExt cx="0" cy="0"/>
+        </a:xfrm>
+      </p:grpSpPr>
+      <p:sp>
+        <p:nvSpPr>
+          <p:cNvPr id="2" name="Slide Image Placeholder 1"/>
+          <p:cNvSpPr>
+            <a:spLocks noGrp="1"/>
+          </p:cNvSpPr>
+          <p:nvPr>
+            <p:ph type="sldImg" idx="2"/>
+          </p:nvPr>
+        </p:nvSpPr>
+        <p:spPr/>
+      </p:sp>
+      <p:sp>
+        <p:nvSpPr>
+          <p:cNvPr id="3" name="Notes Placeholder 2"/>
+          <p:cNvSpPr>
+            <a:spLocks noGrp="1"/>
+          </p:cNvSpPr>
+          <p:nvPr>
+            <p:ph type="body" idx="3" sz="quarter"/>
+          </p:nvPr>
+        </p:nvSpPr>
+        <p:spPr/>
+        <p:txBody>
+          <a:bodyPr/>
+          <a:lstStyle/>
+          <a:p>
+            <a:r>
+              <a:t>After approval, a complete email with every reference known goes straight to the organisation (mock in the demo). Anything else becomes a pre-filled pack: an online form, a phone call, or a letter missing something only the customer has, such as meter readings. Tapping the pack fills it in with the customer's details at that moment, never stored, with what to add and the organisation's link. I've sent it moves it to sent.</a:t>
+            </a:r>
+          </a:p>
+        </p:txBody>
+      </p:sp>
+      <p:sp>
+        <p:nvSpPr>
+          <p:cNvPr id="4" name="Slide Number Placeholder 3"/>
+          <p:cNvSpPr>
+            <a:spLocks noGrp="1"/>
+          </p:cNvSpPr>
+          <p:nvPr>
+            <p:ph type="sldNum" idx="5" sz="quarter"/>
+          </p:nvPr>
+        </p:nvSpPr>
+        <p:spPr/>
+      </p:sp>
+    </p:spTree>
+  </p:cSld>
+  <p:clrMapOvr>
+    <a:masterClrMapping/>
+  </p:clrMapOvr>
+</p:notes>
+</file>
+
+<file path=ppt/notesSlides/notesSlide19.xml><?xml version="1.0" encoding="utf-8"?>
+<p:notes xmlns:a="http://schemas.openxmlformats.org/drawingml/2006/main" xmlns:p="http://schemas.openxmlformats.org/presentationml/2006/main" xmlns:r="http://schemas.openxmlformats.org/officeDocument/2006/relationships">
+  <p:cSld>
+    <p:spTree>
+      <p:nvGrpSpPr>
+        <p:cNvPr id="1" name=""/>
+        <p:cNvGrpSpPr/>
+        <p:nvPr/>
+      </p:nvGrpSpPr>
+      <p:grpSpPr>
+        <a:xfrm>
+          <a:off x="0" y="0"/>
+          <a:ext cx="0" cy="0"/>
+          <a:chOff x="0" y="0"/>
+          <a:chExt cx="0" cy="0"/>
+        </a:xfrm>
+      </p:grpSpPr>
+      <p:sp>
+        <p:nvSpPr>
+          <p:cNvPr id="2" name="Slide Image Placeholder 1"/>
+          <p:cNvSpPr>
+            <a:spLocks noGrp="1"/>
+          </p:cNvSpPr>
+          <p:nvPr>
+            <p:ph type="sldImg" idx="2"/>
+          </p:nvPr>
+        </p:nvSpPr>
+        <p:spPr/>
+      </p:sp>
+      <p:sp>
+        <p:nvSpPr>
+          <p:cNvPr id="3" name="Notes Placeholder 2"/>
+          <p:cNvSpPr>
+            <a:spLocks noGrp="1"/>
+          </p:cNvSpPr>
+          <p:nvPr>
+            <p:ph type="body" idx="3" sz="quarter"/>
+          </p:nvPr>
+        </p:nvSpPr>
+        <p:spPr/>
+        <p:txBody>
+          <a:bodyPr/>
+          <a:lstStyle/>
+          <a:p>
+            <a:r>
+              <a:t>Integration fixtures run the real network against the LLM. Each synthetic customer has its providers and life facts written down; keyword checks cover names, and an LLM judge (gist) checks inferred facts, that the plan marks exactly the legal duties, and that drafts invent no dates or fees. The first run caught a real bug: get_transactions trusted a customer ID written by the LLM, so one customer's session could read another's payments. It now reads only the case the session opened.</a:t>
+            </a:r>
+          </a:p>
+        </p:txBody>
+      </p:sp>
+      <p:sp>
+        <p:nvSpPr>
+          <p:cNvPr id="4" name="Slide Number Placeholder 3"/>
+          <p:cNvSpPr>
+            <a:spLocks noGrp="1"/>
+          </p:cNvSpPr>
+          <p:nvPr>
+            <p:ph type="sldNum" idx="5" sz="quarter"/>
+          </p:nvPr>
+        </p:nvSpPr>
+        <p:spPr/>
+      </p:sp>
+    </p:spTree>
   </p:cSld>
   <p:clrMapOvr>
     <a:masterClrMapping/>
@@ -1795,10 +1929,8 @@
           <a:lstStyle/>
           <a:p>
             <a:r>
-              <a:rPr lang="en-US" dirty="0"/>
-              <a:t>Same agents and rules behind both doors. The bank route is the strongest because the bank already holds the payments and the references; standalone shows the product works for everyone.</a:t>
-            </a:r>
-            <a:endParaRPr lang="en-US" dirty="0"/>
+              <a:t>Same agents and rules behind both doors. The bank route is the strongest because the bank already holds the payments and the references; standalone shows the product works for everyone. A guest who signs out comes back with their case reference and a resume code shown once when the case starts; only a salted hash is stored, and five wrong codes lock it.</a:t>
+            </a:r>
           </a:p>
         </p:txBody>
       </p:sp>
@@ -4132,7 +4264,7 @@
                   <a:schemeClr val="tx2"/>
                 </a:solidFill>
               </a:rPr>
-              <a:t>My move: the customer always knows where things stand</a:t>
+              <a:t>The app always shows the next step</a:t>
             </a:r>
             <a:endParaRPr lang="en-US" sz="3400" dirty="0"/>
           </a:p>
@@ -4596,7 +4728,7 @@
                   <a:schemeClr val="tx2"/>
                 </a:solidFill>
               </a:rPr>
-              <a:t>Waiting for your approval (15)</a:t>
+              <a:t>Approve your 15 letters</a:t>
             </a:r>
             <a:endParaRPr lang="en-US" sz="1500" dirty="0"/>
           </a:p>
@@ -5380,7 +5512,7 @@
                   <a:schemeClr val="accent6"/>
                 </a:solidFill>
               </a:rPr>
-              <a:t>Portal page at /status, refreshed every 5 seconds</a:t>
+              <a:t>House Move app: Move, Chat and Account tabs</a:t>
             </a:r>
             <a:endParaRPr lang="en-US" sz="1200" dirty="0"/>
           </a:p>
@@ -5460,7 +5592,7 @@
                   <a:schemeClr val="tx2"/>
                 </a:solidFill>
               </a:rPr>
-              <a:t>Stage and next step</a:t>
+              <a:t>One next step at a time</a:t>
             </a:r>
             <a:endParaRPr lang="en-US" sz="1700" dirty="0"/>
           </a:p>
@@ -5474,7 +5606,7 @@
                   <a:schemeClr val="tx1"/>
                 </a:solidFill>
               </a:rPr>
-              <a:t>Seven stages, what is waiting on you, and recent activity</a:t>
+              <a:t>A card on the Move tab and under every chat reply takes you there</a:t>
             </a:r>
             <a:endParaRPr lang="en-US" sz="1700" dirty="0"/>
           </a:p>
@@ -5554,7 +5686,7 @@
                   <a:schemeClr val="tx2"/>
                 </a:solidFill>
               </a:rPr>
-              <a:t>Read, then approve</a:t>
+              <a:t>Approve all, or one by one</a:t>
             </a:r>
             <a:endParaRPr lang="en-US" sz="1700" dirty="0"/>
           </a:p>
@@ -5568,7 +5700,7 @@
                   <a:schemeClr val="tx1"/>
                 </a:solidFill>
               </a:rPr>
-              <a:t>A click from your own signed-in browser approves the exact wording you read</a:t>
+              <a:t>Read every letter, then approve, change or skip it, tied to that exact wording</a:t>
             </a:r>
             <a:endParaRPr lang="en-US" sz="1700" dirty="0"/>
           </a:p>
@@ -5722,6 +5854,542 @@
 </file>
 
 <file path=ppt/slides/slide12.xml><?xml version="1.0" encoding="utf-8"?>
+<p:sld xmlns:a="http://schemas.openxmlformats.org/drawingml/2006/main" xmlns:r="http://schemas.openxmlformats.org/officeDocument/2006/relationships" xmlns:p="http://schemas.openxmlformats.org/presentationml/2006/main">
+  <p:cSld name="Slide 4">
+    <p:spTree>
+      <p:nvGrpSpPr>
+        <p:cNvPr id="1" name=""/>
+        <p:cNvGrpSpPr/>
+        <p:nvPr/>
+      </p:nvGrpSpPr>
+      <p:grpSpPr>
+        <a:xfrm>
+          <a:off x="0" y="0"/>
+          <a:ext cx="0" cy="0"/>
+          <a:chOff x="0" y="0"/>
+          <a:chExt cx="0" cy="0"/>
+        </a:xfrm>
+      </p:grpSpPr>
+      <p:sp>
+        <p:nvSpPr>
+          <p:cNvPr id="2" name="Text 0"/>
+          <p:cNvSpPr/>
+          <p:nvPr>
+            <p:ph idx="100" type="title" hasCustomPrompt="1"/>
+          </p:nvPr>
+        </p:nvSpPr>
+        <p:spPr>
+          <a:xfrm>
+            <a:off x="548640" y="320040"/>
+            <a:ext cx="11064240" cy="868680"/>
+          </a:xfrm>
+          <a:prstGeom prst="rect">
+            <a:avLst/>
+          </a:prstGeom>
+          <a:noFill/>
+          <a:ln/>
+        </p:spPr>
+        <p:txBody>
+          <a:bodyPr wrap="square" lIns="0" tIns="0" rIns="0" bIns="0" rtlCol="0" anchor="ctr"/>
+          <a:lstStyle/>
+          <a:p>
+            <a:pPr indent="0" marL="0">
+              <a:buNone/>
+            </a:pPr>
+            <a:r>
+              <a:rPr lang="en-US" sz="3400" b="1" dirty="0">
+                <a:solidFill>
+                  <a:schemeClr val="tx2"/>
+                </a:solidFill>
+              </a:rPr>
+              <a:t>Sent for you, or ready for you to send</a:t>
+            </a:r>
+            <a:endParaRPr lang="en-US" sz="3400" dirty="0"/>
+          </a:p>
+        </p:txBody>
+      </p:sp>
+      <p:sp>
+        <p:nvSpPr>
+          <p:cNvPr id="3" name="Bank customer card"/>
+          <p:cNvSpPr/>
+          <p:nvPr/>
+        </p:nvSpPr>
+        <p:spPr>
+          <a:xfrm>
+            <a:off x="548640" y="1463040"/>
+            <a:ext cx="5394960" cy="4480560"/>
+          </a:xfrm>
+          <a:prstGeom prst="roundRect">
+            <a:avLst>
+              <a:gd name="adj" fmla="val 2449"/>
+            </a:avLst>
+          </a:prstGeom>
+          <a:solidFill>
+            <a:schemeClr val="bg2"/>
+          </a:solidFill>
+          <a:ln/>
+        </p:spPr>
+      </p:sp>
+      <p:sp>
+        <p:nvSpPr>
+          <p:cNvPr id="4" name="Bank customer circle"/>
+          <p:cNvSpPr/>
+          <p:nvPr/>
+        </p:nvSpPr>
+        <p:spPr>
+          <a:xfrm>
+            <a:off x="868680" y="1737360"/>
+            <a:ext cx="822960" cy="822960"/>
+          </a:xfrm>
+          <a:prstGeom prst="ellipse">
+            <a:avLst/>
+          </a:prstGeom>
+          <a:solidFill>
+            <a:schemeClr val="accent2"/>
+          </a:solidFill>
+          <a:ln/>
+        </p:spPr>
+      </p:sp>
+      <p:pic>
+        <p:nvPicPr>
+          <p:cNvPr id="5" name="Sent for you icon" descr="preencoded.png">    </p:cNvPr>
+          <p:cNvPicPr>
+            <a:picLocks noChangeAspect="1"/>
+          </p:cNvPicPr>
+          <p:nvPr/>
+        </p:nvPicPr>
+        <p:blipFill>
+          <a:blip r:embed="rId1"/>
+          <a:stretch>
+            <a:fillRect/>
+          </a:stretch>
+        </p:blipFill>
+        <p:spPr>
+          <a:xfrm>
+            <a:off x="1074420" y="1943100"/>
+            <a:ext cx="411480" cy="411480"/>
+          </a:xfrm>
+          <a:prstGeom prst="rect">
+            <a:avLst/>
+          </a:prstGeom>
+        </p:spPr>
+      </p:pic>
+      <p:sp>
+        <p:nvSpPr>
+          <p:cNvPr id="6" name="Text 3"/>
+          <p:cNvSpPr txBox="1"/>
+          <p:nvPr/>
+        </p:nvSpPr>
+        <p:spPr>
+          <a:xfrm>
+            <a:off x="1874520" y="1737360"/>
+            <a:ext cx="3840480" cy="457200"/>
+          </a:xfrm>
+          <a:prstGeom prst="rect">
+            <a:avLst/>
+          </a:prstGeom>
+          <a:noFill/>
+          <a:ln/>
+        </p:spPr>
+        <p:txBody>
+          <a:bodyPr wrap="square" lIns="0" tIns="0" rIns="0" bIns="0" rtlCol="0" anchor="ctr"/>
+          <a:lstStyle/>
+          <a:p>
+            <a:pPr indent="0" marL="0">
+              <a:buNone/>
+            </a:pPr>
+            <a:r>
+              <a:rPr lang="en-US" sz="2400" b="1" dirty="0">
+                <a:solidFill>
+                  <a:schemeClr val="tx2"/>
+                </a:solidFill>
+              </a:rPr>
+              <a:t>Sent for you</a:t>
+            </a:r>
+            <a:endParaRPr lang="en-US" sz="2400" dirty="0"/>
+          </a:p>
+        </p:txBody>
+      </p:sp>
+      <p:sp>
+        <p:nvSpPr>
+          <p:cNvPr id="7" name="Text 4"/>
+          <p:cNvSpPr txBox="1"/>
+          <p:nvPr/>
+        </p:nvSpPr>
+        <p:spPr>
+          <a:xfrm>
+            <a:off x="1874520" y="2194560"/>
+            <a:ext cx="3840480" cy="411480"/>
+          </a:xfrm>
+          <a:prstGeom prst="rect">
+            <a:avLst/>
+          </a:prstGeom>
+          <a:noFill/>
+          <a:ln/>
+        </p:spPr>
+        <p:txBody>
+          <a:bodyPr wrap="square" lIns="0" tIns="0" rIns="0" bIns="0" rtlCol="0" anchor="ctr"/>
+          <a:lstStyle/>
+          <a:p>
+            <a:pPr indent="0" marL="0">
+              <a:buNone/>
+            </a:pPr>
+            <a:r>
+              <a:rPr lang="en-US" sz="1500" i="1" dirty="0">
+                <a:solidFill>
+                  <a:schemeClr val="accent6"/>
+                </a:solidFill>
+              </a:rPr>
+              <a:t>Complete emails with every reference known</a:t>
+            </a:r>
+            <a:endParaRPr lang="en-US" sz="1500" dirty="0"/>
+          </a:p>
+        </p:txBody>
+      </p:sp>
+      <p:sp>
+        <p:nvSpPr>
+          <p:cNvPr id="8" name="Text 5"/>
+          <p:cNvSpPr txBox="1"/>
+          <p:nvPr/>
+        </p:nvSpPr>
+        <p:spPr>
+          <a:xfrm>
+            <a:off x="914400" y="2926080"/>
+            <a:ext cx="4754880" cy="2743200"/>
+          </a:xfrm>
+          <a:prstGeom prst="rect">
+            <a:avLst/>
+          </a:prstGeom>
+          <a:noFill/>
+          <a:ln/>
+        </p:spPr>
+        <p:txBody>
+          <a:bodyPr wrap="square" lIns="0" tIns="0" rIns="0" bIns="0" rtlCol="0" anchor="t"/>
+          <a:lstStyle/>
+          <a:p>
+            <a:pPr marL="342900" indent="-342900">
+              <a:spcAft>
+                <a:spcPts val="1000"/>
+              </a:spcAft>
+              <a:buSzPct val="100000"/>
+              <a:buChar char="•"/>
+            </a:pPr>
+            <a:r>
+              <a:rPr lang="en-US" sz="1700" dirty="0">
+                <a:solidFill>
+                  <a:schemeClr val="tx1"/>
+                </a:solidFill>
+              </a:rPr>
+              <a:t>Account, policy and licence numbers filled in from your Direct Debits</a:t>
+            </a:r>
+            <a:endParaRPr lang="en-US" sz="1700" dirty="0"/>
+          </a:p>
+          <a:p>
+            <a:pPr marL="342900" indent="-342900">
+              <a:spcAft>
+                <a:spcPts val="1000"/>
+              </a:spcAft>
+              <a:buSzPct val="100000"/>
+              <a:buChar char="•"/>
+            </a:pPr>
+            <a:r>
+              <a:rPr lang="en-US" sz="1700" dirty="0">
+                <a:solidFill>
+                  <a:schemeClr val="tx1"/>
+                </a:solidFill>
+              </a:rPr>
+              <a:t>Delivered straight to the organisation</a:t>
+            </a:r>
+            <a:endParaRPr lang="en-US" sz="1700" dirty="0"/>
+          </a:p>
+          <a:p>
+            <a:pPr marL="342900" indent="-342900">
+              <a:spcAft>
+                <a:spcPts val="1000"/>
+              </a:spcAft>
+              <a:buSzPct val="100000"/>
+              <a:buChar char="•"/>
+            </a:pPr>
+            <a:r>
+              <a:rPr lang="en-US" sz="1700" dirty="0">
+                <a:solidFill>
+                  <a:schemeClr val="tx1"/>
+                </a:solidFill>
+              </a:rPr>
+              <a:t>Replies come back here; the bank updates its own records</a:t>
+            </a:r>
+            <a:endParaRPr lang="en-US" sz="1700" dirty="0"/>
+          </a:p>
+        </p:txBody>
+      </p:sp>
+      <p:sp>
+        <p:nvSpPr>
+          <p:cNvPr id="9" name="Standalone card"/>
+          <p:cNvSpPr/>
+          <p:nvPr/>
+        </p:nvSpPr>
+        <p:spPr>
+          <a:xfrm>
+            <a:off x="6217920" y="1463040"/>
+            <a:ext cx="5394960" cy="4480560"/>
+          </a:xfrm>
+          <a:prstGeom prst="roundRect">
+            <a:avLst>
+              <a:gd name="adj" fmla="val 2449"/>
+            </a:avLst>
+          </a:prstGeom>
+          <a:solidFill>
+            <a:schemeClr val="bg2"/>
+          </a:solidFill>
+          <a:ln/>
+        </p:spPr>
+      </p:sp>
+      <p:sp>
+        <p:nvSpPr>
+          <p:cNvPr id="10" name="Standalone circle"/>
+          <p:cNvSpPr/>
+          <p:nvPr/>
+        </p:nvSpPr>
+        <p:spPr>
+          <a:xfrm>
+            <a:off x="6537960" y="1737360"/>
+            <a:ext cx="822960" cy="822960"/>
+          </a:xfrm>
+          <a:prstGeom prst="ellipse">
+            <a:avLst/>
+          </a:prstGeom>
+          <a:solidFill>
+            <a:schemeClr val="accent1"/>
+          </a:solidFill>
+          <a:ln/>
+        </p:spPr>
+      </p:sp>
+      <p:pic>
+        <p:nvPicPr>
+          <p:cNvPr id="11" name="Ready for you to send icon" descr="preencoded.png">    </p:cNvPr>
+          <p:cNvPicPr>
+            <a:picLocks noChangeAspect="1"/>
+          </p:cNvPicPr>
+          <p:nvPr/>
+        </p:nvPicPr>
+        <p:blipFill>
+          <a:blip r:embed="rId2"/>
+          <a:stretch>
+            <a:fillRect/>
+          </a:stretch>
+        </p:blipFill>
+        <p:spPr>
+          <a:xfrm>
+            <a:off x="6743700" y="1943100"/>
+            <a:ext cx="411480" cy="411480"/>
+          </a:xfrm>
+          <a:prstGeom prst="rect">
+            <a:avLst/>
+          </a:prstGeom>
+        </p:spPr>
+      </p:pic>
+      <p:sp>
+        <p:nvSpPr>
+          <p:cNvPr id="12" name="Text 8"/>
+          <p:cNvSpPr txBox="1"/>
+          <p:nvPr/>
+        </p:nvSpPr>
+        <p:spPr>
+          <a:xfrm>
+            <a:off x="7543800" y="1737360"/>
+            <a:ext cx="3840480" cy="457200"/>
+          </a:xfrm>
+          <a:prstGeom prst="rect">
+            <a:avLst/>
+          </a:prstGeom>
+          <a:noFill/>
+          <a:ln/>
+        </p:spPr>
+        <p:txBody>
+          <a:bodyPr wrap="square" lIns="0" tIns="0" rIns="0" bIns="0" rtlCol="0" anchor="ctr"/>
+          <a:lstStyle/>
+          <a:p>
+            <a:pPr indent="0" marL="0">
+              <a:buNone/>
+            </a:pPr>
+            <a:r>
+              <a:rPr lang="en-US" sz="2400" b="1" dirty="0">
+                <a:solidFill>
+                  <a:schemeClr val="tx2"/>
+                </a:solidFill>
+              </a:rPr>
+              <a:t>Ready for you to send</a:t>
+            </a:r>
+            <a:endParaRPr lang="en-US" sz="2400" dirty="0"/>
+          </a:p>
+        </p:txBody>
+      </p:sp>
+      <p:sp>
+        <p:nvSpPr>
+          <p:cNvPr id="13" name="Text 9"/>
+          <p:cNvSpPr txBox="1"/>
+          <p:nvPr/>
+        </p:nvSpPr>
+        <p:spPr>
+          <a:xfrm>
+            <a:off x="7543800" y="2194560"/>
+            <a:ext cx="3840480" cy="411480"/>
+          </a:xfrm>
+          <a:prstGeom prst="rect">
+            <a:avLst/>
+          </a:prstGeom>
+          <a:noFill/>
+          <a:ln/>
+        </p:spPr>
+        <p:txBody>
+          <a:bodyPr wrap="square" lIns="0" tIns="0" rIns="0" bIns="0" rtlCol="0" anchor="ctr"/>
+          <a:lstStyle/>
+          <a:p>
+            <a:pPr indent="0" marL="0">
+              <a:buNone/>
+            </a:pPr>
+            <a:r>
+              <a:rPr lang="en-US" sz="1500" i="1" dirty="0">
+                <a:solidFill>
+                  <a:schemeClr val="accent6"/>
+                </a:solidFill>
+              </a:rPr>
+              <a:t>Forms, calls, or details only you have</a:t>
+            </a:r>
+            <a:endParaRPr lang="en-US" sz="1500" dirty="0"/>
+          </a:p>
+        </p:txBody>
+      </p:sp>
+      <p:sp>
+        <p:nvSpPr>
+          <p:cNvPr id="14" name="Text 10"/>
+          <p:cNvSpPr txBox="1"/>
+          <p:nvPr/>
+        </p:nvSpPr>
+        <p:spPr>
+          <a:xfrm>
+            <a:off x="6583680" y="2926080"/>
+            <a:ext cx="4754880" cy="2743200"/>
+          </a:xfrm>
+          <a:prstGeom prst="rect">
+            <a:avLst/>
+          </a:prstGeom>
+          <a:noFill/>
+          <a:ln/>
+        </p:spPr>
+        <p:txBody>
+          <a:bodyPr wrap="square" lIns="0" tIns="0" rIns="0" bIns="0" rtlCol="0" anchor="t"/>
+          <a:lstStyle/>
+          <a:p>
+            <a:pPr marL="342900" indent="-342900">
+              <a:spcAft>
+                <a:spcPts val="1000"/>
+              </a:spcAft>
+              <a:buSzPct val="100000"/>
+              <a:buChar char="•"/>
+            </a:pPr>
+            <a:r>
+              <a:rPr lang="en-US" sz="1700" dirty="0">
+                <a:solidFill>
+                  <a:schemeClr val="tx1"/>
+                </a:solidFill>
+              </a:rPr>
+              <a:t>Tap the letter: filled in with your details as you open it</a:t>
+            </a:r>
+            <a:endParaRPr lang="en-US" sz="1700" dirty="0"/>
+          </a:p>
+          <a:p>
+            <a:pPr marL="342900" indent="-342900">
+              <a:spcAft>
+                <a:spcPts val="1000"/>
+              </a:spcAft>
+              <a:buSzPct val="100000"/>
+              <a:buChar char="•"/>
+            </a:pPr>
+            <a:r>
+              <a:rPr lang="en-US" sz="1700" dirty="0">
+                <a:solidFill>
+                  <a:schemeClr val="tx1"/>
+                </a:solidFill>
+              </a:rPr>
+              <a:t>What to add, then Copy text and Open the organisation's page</a:t>
+            </a:r>
+            <a:endParaRPr lang="en-US" sz="1700" dirty="0"/>
+          </a:p>
+          <a:p>
+            <a:pPr marL="342900" indent="-342900">
+              <a:spcAft>
+                <a:spcPts val="1000"/>
+              </a:spcAft>
+              <a:buSzPct val="100000"/>
+              <a:buChar char="•"/>
+            </a:pPr>
+            <a:r>
+              <a:rPr lang="en-US" sz="1700" dirty="0">
+                <a:solidFill>
+                  <a:schemeClr val="tx1"/>
+                </a:solidFill>
+              </a:rPr>
+              <a:t>Tap "I've sent it" and the plan shows it as sent</a:t>
+            </a:r>
+            <a:endParaRPr lang="en-US" sz="1700" dirty="0"/>
+          </a:p>
+        </p:txBody>
+      </p:sp>
+      <p:sp>
+        <p:nvSpPr>
+          <p:cNvPr id="25" name="Slide Number Placeholder 0"/>
+          <p:cNvSpPr>
+            <a:spLocks noGrp="1"/>
+          </p:cNvSpPr>
+          <p:nvPr>
+            <p:ph type="sldNum" sz="quarter" idx="4294967295"/>
+          </p:nvPr>
+        </p:nvSpPr>
+        <p:spPr>
+          <a:xfrm>
+            <a:off x="11247120" y="6400800"/>
+            <a:ext cx="457200" cy="274320"/>
+          </a:xfrm>
+          <a:prstGeom prst="rect">
+            <a:avLst/>
+          </a:prstGeom>
+          <a:extLst>
+            <a:ext uri="{C572A759-6A51-4108-AA02-DFA0A04FC94B}">
+              <ma14:wrappingTextBoxFlag xmlns:ma14="http://schemas.microsoft.com/office/mac/drawingml/2011/main" val="0"/>
+            </a:ext>
+          </a:extLst>
+        </p:spPr>
+        <p:txBody>
+          <a:bodyPr/>
+          <a:lstStyle>
+            <a:lvl1pPr>
+              <a:defRPr sz="1000">
+                <a:solidFill>
+                  <a:schemeClr val="accent6"/>
+                </a:solidFill>
+              </a:defRPr>
+            </a:lvl1pPr>
+          </a:lstStyle>
+          <a:p>
+            <a:pPr algn="r"/>
+            <a:fld id="{F7021451-1387-4CA6-816F-3879F97B5CBC}" type="slidenum">
+              <a:rPr b="0" lang="en-US"/>
+              <a:t>4</a:t>
+            </a:fld>
+            <a:endParaRPr lang="en-US"/>
+          </a:p>
+        </p:txBody>
+      </p:sp>
+    </p:spTree>
+  </p:cSld>
+  <p:clrMapOvr>
+    <a:masterClrMapping/>
+  </p:clrMapOvr>
+</p:sld>
+</file>
+
+<file path=ppt/slides/slide13.xml><?xml version="1.0" encoding="utf-8"?>
 <p:sld xmlns:a="http://schemas.openxmlformats.org/drawingml/2006/main" xmlns:r="http://schemas.openxmlformats.org/officeDocument/2006/relationships" xmlns:p="http://schemas.openxmlformats.org/presentationml/2006/main">
   <p:cSld name="Slide 12">
     <p:spTree>
@@ -6321,7 +6989,7 @@
 </p:sld>
 </file>
 
-<file path=ppt/slides/slide13.xml><?xml version="1.0" encoding="utf-8"?>
+<file path=ppt/slides/slide14.xml><?xml version="1.0" encoding="utf-8"?>
 <p:sld xmlns:a="http://schemas.openxmlformats.org/drawingml/2006/main" xmlns:r="http://schemas.openxmlformats.org/officeDocument/2006/relationships" xmlns:p="http://schemas.openxmlformats.org/presentationml/2006/main">
   <p:cSld name="Slide 13">
     <p:spTree>
@@ -6936,7 +7604,7 @@
                   <a:schemeClr val="accent6"/>
                 </a:solidFill>
               </a:rPr>
-              <a:t>Checked table plus the official CCW checker</a:t>
+              <a:t>Ofwat's official area maps, live</a:t>
             </a:r>
             <a:endParaRPr lang="en-US" sz="1300" dirty="0"/>
           </a:p>
@@ -6976,7 +7644,7 @@
                   <a:schemeClr val="tx1"/>
                 </a:solidFill>
               </a:rPr>
-              <a:t>Yorkshire Water (to confirm)</a:t>
+              <a:t>Yorkshire Water, confirmed</a:t>
             </a:r>
             <a:endParaRPr lang="en-US" sz="1500" dirty="0"/>
           </a:p>
@@ -7107,7 +7775,478 @@
 </p:sld>
 </file>
 
-<file path=ppt/slides/slide14.xml><?xml version="1.0" encoding="utf-8"?>
+<file path=ppt/slides/slide15.xml><?xml version="1.0" encoding="utf-8"?>
+<p:sld xmlns:a="http://schemas.openxmlformats.org/drawingml/2006/main" xmlns:r="http://schemas.openxmlformats.org/officeDocument/2006/relationships" xmlns:p="http://schemas.openxmlformats.org/presentationml/2006/main">
+  <p:cSld name="Slide 2">
+    <p:spTree>
+      <p:nvGrpSpPr>
+        <p:cNvPr id="1" name=""/>
+        <p:cNvGrpSpPr/>
+        <p:nvPr/>
+      </p:nvGrpSpPr>
+      <p:grpSpPr>
+        <a:xfrm>
+          <a:off x="0" y="0"/>
+          <a:ext cx="0" cy="0"/>
+          <a:chOff x="0" y="0"/>
+          <a:chExt cx="0" cy="0"/>
+        </a:xfrm>
+      </p:grpSpPr>
+      <p:sp>
+        <p:nvSpPr>
+          <p:cNvPr id="2" name="Text 0"/>
+          <p:cNvSpPr/>
+          <p:nvPr>
+            <p:ph idx="100" type="title" hasCustomPrompt="1"/>
+          </p:nvPr>
+        </p:nvSpPr>
+        <p:spPr>
+          <a:xfrm>
+            <a:off x="548640" y="320040"/>
+            <a:ext cx="11064240" cy="868680"/>
+          </a:xfrm>
+          <a:prstGeom prst="rect">
+            <a:avLst/>
+          </a:prstGeom>
+          <a:noFill/>
+          <a:ln/>
+        </p:spPr>
+        <p:txBody>
+          <a:bodyPr wrap="square" lIns="0" tIns="0" rIns="0" bIns="0" rtlCol="0" anchor="ctr"/>
+          <a:lstStyle/>
+          <a:p>
+            <a:pPr indent="0" marL="0">
+              <a:buNone/>
+            </a:pPr>
+            <a:r>
+              <a:rPr lang="en-US" sz="3400" b="1" dirty="0">
+                <a:solidFill>
+                  <a:schemeClr val="tx2"/>
+                </a:solidFill>
+              </a:rPr>
+              <a:t>Evaluated against ground truth, not just tested</a:t>
+            </a:r>
+            <a:endParaRPr lang="en-US" sz="3400" dirty="0"/>
+          </a:p>
+        </p:txBody>
+      </p:sp>
+      <p:sp>
+        <p:nvSpPr>
+          <p:cNvPr id="3" name="stat card 1"/>
+          <p:cNvSpPr/>
+          <p:nvPr/>
+        </p:nvSpPr>
+        <p:spPr>
+          <a:xfrm>
+            <a:off x="548640" y="1554480"/>
+            <a:ext cx="3474720" cy="2926080"/>
+          </a:xfrm>
+          <a:prstGeom prst="roundRect">
+            <a:avLst>
+              <a:gd name="adj" fmla="val 3750"/>
+            </a:avLst>
+          </a:prstGeom>
+          <a:solidFill>
+            <a:schemeClr val="bg2"/>
+          </a:solidFill>
+          <a:ln/>
+        </p:spPr>
+      </p:sp>
+      <p:sp>
+        <p:nvSpPr>
+          <p:cNvPr id="4" name="stat 1"/>
+          <p:cNvSpPr txBox="1"/>
+          <p:nvPr/>
+        </p:nvSpPr>
+        <p:spPr>
+          <a:xfrm>
+            <a:off x="822960" y="1783080"/>
+            <a:ext cx="2926080" cy="1280160"/>
+          </a:xfrm>
+          <a:prstGeom prst="rect">
+            <a:avLst/>
+          </a:prstGeom>
+          <a:noFill/>
+          <a:ln/>
+        </p:spPr>
+        <p:txBody>
+          <a:bodyPr wrap="square" lIns="0" tIns="0" rIns="0" bIns="0" rtlCol="0" anchor="ctr"/>
+          <a:lstStyle/>
+          <a:p>
+            <a:pPr indent="0" marL="0">
+              <a:buNone/>
+            </a:pPr>
+            <a:r>
+              <a:rPr lang="en-US" sz="6000" b="1" dirty="0">
+                <a:solidFill>
+                  <a:schemeClr val="accent2"/>
+                </a:solidFill>
+                <a:latin typeface="Cambria" pitchFamily="34" charset="0"/>
+                <a:ea typeface="Cambria" pitchFamily="34" charset="-122"/>
+                <a:cs typeface="Cambria" pitchFamily="34" charset="-120"/>
+              </a:rPr>
+              <a:t>5</a:t>
+            </a:r>
+            <a:endParaRPr lang="en-US" sz="6000" dirty="0"/>
+          </a:p>
+        </p:txBody>
+      </p:sp>
+      <p:sp>
+        <p:nvSpPr>
+          <p:cNvPr id="5" name="Text 3"/>
+          <p:cNvSpPr txBox="1"/>
+          <p:nvPr/>
+        </p:nvSpPr>
+        <p:spPr>
+          <a:xfrm>
+            <a:off x="822960" y="3154680"/>
+            <a:ext cx="2926080" cy="1097280"/>
+          </a:xfrm>
+          <a:prstGeom prst="rect">
+            <a:avLst/>
+          </a:prstGeom>
+          <a:noFill/>
+          <a:ln/>
+        </p:spPr>
+        <p:txBody>
+          <a:bodyPr wrap="square" lIns="0" tIns="0" rIns="0" bIns="0" rtlCol="0" anchor="t"/>
+          <a:lstStyle/>
+          <a:p>
+            <a:pPr indent="0" marL="0">
+              <a:buNone/>
+            </a:pPr>
+            <a:r>
+              <a:rPr lang="en-US" sz="1800" dirty="0">
+                <a:solidFill>
+                  <a:schemeClr val="tx1"/>
+                </a:solidFill>
+              </a:rPr>
+              <a:t>customers with written-down ground truth</a:t>
+            </a:r>
+            <a:endParaRPr lang="en-US" sz="1800" dirty="0"/>
+          </a:p>
+        </p:txBody>
+      </p:sp>
+      <p:sp>
+        <p:nvSpPr>
+          <p:cNvPr id="6" name="stat card 2"/>
+          <p:cNvSpPr/>
+          <p:nvPr/>
+        </p:nvSpPr>
+        <p:spPr>
+          <a:xfrm>
+            <a:off x="4297680" y="1554480"/>
+            <a:ext cx="3474720" cy="2926080"/>
+          </a:xfrm>
+          <a:prstGeom prst="roundRect">
+            <a:avLst>
+              <a:gd name="adj" fmla="val 3750"/>
+            </a:avLst>
+          </a:prstGeom>
+          <a:solidFill>
+            <a:schemeClr val="bg2"/>
+          </a:solidFill>
+          <a:ln/>
+        </p:spPr>
+      </p:sp>
+      <p:sp>
+        <p:nvSpPr>
+          <p:cNvPr id="7" name="stat 2"/>
+          <p:cNvSpPr txBox="1"/>
+          <p:nvPr/>
+        </p:nvSpPr>
+        <p:spPr>
+          <a:xfrm>
+            <a:off x="4572000" y="1783080"/>
+            <a:ext cx="2926080" cy="1280160"/>
+          </a:xfrm>
+          <a:prstGeom prst="rect">
+            <a:avLst/>
+          </a:prstGeom>
+          <a:noFill/>
+          <a:ln/>
+        </p:spPr>
+        <p:txBody>
+          <a:bodyPr wrap="square" lIns="0" tIns="0" rIns="0" bIns="0" rtlCol="0" anchor="ctr"/>
+          <a:lstStyle/>
+          <a:p>
+            <a:pPr indent="0" marL="0">
+              <a:buNone/>
+            </a:pPr>
+            <a:r>
+              <a:rPr lang="en-US" sz="6000" b="1" dirty="0">
+                <a:solidFill>
+                  <a:schemeClr val="accent1"/>
+                </a:solidFill>
+                <a:latin typeface="Cambria" pitchFamily="34" charset="0"/>
+                <a:ea typeface="Cambria" pitchFamily="34" charset="-122"/>
+                <a:cs typeface="Cambria" pitchFamily="34" charset="-120"/>
+              </a:rPr>
+              <a:t>12</a:t>
+            </a:r>
+            <a:endParaRPr lang="en-US" sz="6000" dirty="0"/>
+          </a:p>
+        </p:txBody>
+      </p:sp>
+      <p:sp>
+        <p:nvSpPr>
+          <p:cNvPr id="8" name="Text 6"/>
+          <p:cNvSpPr txBox="1"/>
+          <p:nvPr/>
+        </p:nvSpPr>
+        <p:spPr>
+          <a:xfrm>
+            <a:off x="4572000" y="3154680"/>
+            <a:ext cx="2926080" cy="1097280"/>
+          </a:xfrm>
+          <a:prstGeom prst="rect">
+            <a:avLst/>
+          </a:prstGeom>
+          <a:noFill/>
+          <a:ln/>
+        </p:spPr>
+        <p:txBody>
+          <a:bodyPr wrap="square" lIns="0" tIns="0" rIns="0" bIns="0" rtlCol="0" anchor="t"/>
+          <a:lstStyle/>
+          <a:p>
+            <a:pPr indent="0" marL="0">
+              <a:buNone/>
+            </a:pPr>
+            <a:r>
+              <a:rPr lang="en-US" sz="1800" dirty="0">
+                <a:solidFill>
+                  <a:schemeClr val="tx1"/>
+                </a:solidFill>
+              </a:rPr>
+              <a:t>live AI conversations checked on every run</a:t>
+            </a:r>
+            <a:endParaRPr lang="en-US" sz="1800" dirty="0"/>
+          </a:p>
+        </p:txBody>
+      </p:sp>
+      <p:sp>
+        <p:nvSpPr>
+          <p:cNvPr id="9" name="stat card 3"/>
+          <p:cNvSpPr/>
+          <p:nvPr/>
+        </p:nvSpPr>
+        <p:spPr>
+          <a:xfrm>
+            <a:off x="8046720" y="1554480"/>
+            <a:ext cx="3474720" cy="2926080"/>
+          </a:xfrm>
+          <a:prstGeom prst="roundRect">
+            <a:avLst>
+              <a:gd name="adj" fmla="val 3750"/>
+            </a:avLst>
+          </a:prstGeom>
+          <a:solidFill>
+            <a:schemeClr val="bg2"/>
+          </a:solidFill>
+          <a:ln/>
+        </p:spPr>
+      </p:sp>
+      <p:sp>
+        <p:nvSpPr>
+          <p:cNvPr id="10" name="stat 3"/>
+          <p:cNvSpPr txBox="1"/>
+          <p:nvPr/>
+        </p:nvSpPr>
+        <p:spPr>
+          <a:xfrm>
+            <a:off x="8321040" y="1783080"/>
+            <a:ext cx="2926080" cy="1280160"/>
+          </a:xfrm>
+          <a:prstGeom prst="rect">
+            <a:avLst/>
+          </a:prstGeom>
+          <a:noFill/>
+          <a:ln/>
+        </p:spPr>
+        <p:txBody>
+          <a:bodyPr wrap="square" lIns="0" tIns="0" rIns="0" bIns="0" rtlCol="0" anchor="ctr"/>
+          <a:lstStyle/>
+          <a:p>
+            <a:pPr indent="0" marL="0">
+              <a:buNone/>
+            </a:pPr>
+            <a:r>
+              <a:rPr lang="en-US" sz="6000" b="1" dirty="0">
+                <a:solidFill>
+                  <a:schemeClr val="accent5"/>
+                </a:solidFill>
+                <a:latin typeface="Cambria" pitchFamily="34" charset="0"/>
+                <a:ea typeface="Cambria" pitchFamily="34" charset="-122"/>
+                <a:cs typeface="Cambria" pitchFamily="34" charset="-120"/>
+              </a:rPr>
+              <a:t>1</a:t>
+            </a:r>
+            <a:endParaRPr lang="en-US" sz="6000" dirty="0"/>
+          </a:p>
+        </p:txBody>
+      </p:sp>
+      <p:sp>
+        <p:nvSpPr>
+          <p:cNvPr id="11" name="Text 9"/>
+          <p:cNvSpPr txBox="1"/>
+          <p:nvPr/>
+        </p:nvSpPr>
+        <p:spPr>
+          <a:xfrm>
+            <a:off x="8321040" y="3154680"/>
+            <a:ext cx="2926080" cy="1097280"/>
+          </a:xfrm>
+          <a:prstGeom prst="rect">
+            <a:avLst/>
+          </a:prstGeom>
+          <a:noFill/>
+          <a:ln/>
+        </p:spPr>
+        <p:txBody>
+          <a:bodyPr wrap="square" lIns="0" tIns="0" rIns="0" bIns="0" rtlCol="0" anchor="t"/>
+          <a:lstStyle/>
+          <a:p>
+            <a:pPr indent="0" marL="0">
+              <a:buNone/>
+            </a:pPr>
+            <a:r>
+              <a:rPr lang="en-US" sz="1800" dirty="0">
+                <a:solidFill>
+                  <a:schemeClr val="tx1"/>
+                </a:solidFill>
+              </a:rPr>
+              <a:t>cross-customer data leak caught, and fixed</a:t>
+            </a:r>
+            <a:endParaRPr lang="en-US" sz="1800" dirty="0"/>
+          </a:p>
+        </p:txBody>
+      </p:sp>
+      <p:sp>
+        <p:nvSpPr>
+          <p:cNvPr id="12" name="Text 10"/>
+          <p:cNvSpPr txBox="1"/>
+          <p:nvPr/>
+        </p:nvSpPr>
+        <p:spPr>
+          <a:xfrm>
+            <a:off x="548640" y="4846320"/>
+            <a:ext cx="11064240" cy="731520"/>
+          </a:xfrm>
+          <a:prstGeom prst="rect">
+            <a:avLst/>
+          </a:prstGeom>
+          <a:noFill/>
+          <a:ln/>
+        </p:spPr>
+        <p:txBody>
+          <a:bodyPr wrap="square" lIns="0" tIns="0" rIns="0" bIns="0" rtlCol="0" anchor="ctr"/>
+          <a:lstStyle/>
+          <a:p>
+            <a:pPr indent="0" marL="0">
+              <a:buNone/>
+            </a:pPr>
+            <a:r>
+              <a:rPr lang="en-US" sz="1800" dirty="0">
+                <a:solidFill>
+                  <a:schemeClr val="tx1"/>
+                </a:solidFill>
+              </a:rPr>
+              <a:t>Discovery must find what each customer's payments show; the plan must mark exactly the legal duties; drafts must state no date or fee the rules do not; a changed letter must need approving again.</a:t>
+            </a:r>
+            <a:endParaRPr lang="en-US" sz="1800" dirty="0"/>
+          </a:p>
+        </p:txBody>
+      </p:sp>
+      <p:sp>
+        <p:nvSpPr>
+          <p:cNvPr id="13" name="Text 11"/>
+          <p:cNvSpPr txBox="1"/>
+          <p:nvPr/>
+        </p:nvSpPr>
+        <p:spPr>
+          <a:xfrm>
+            <a:off x="548640" y="5760720"/>
+            <a:ext cx="11064240" cy="320040"/>
+          </a:xfrm>
+          <a:prstGeom prst="rect">
+            <a:avLst/>
+          </a:prstGeom>
+          <a:noFill/>
+          <a:ln/>
+        </p:spPr>
+        <p:txBody>
+          <a:bodyPr wrap="square" lIns="0" tIns="0" rIns="0" bIns="0" rtlCol="0" anchor="ctr"/>
+          <a:lstStyle/>
+          <a:p>
+            <a:pPr indent="0" marL="0">
+              <a:buNone/>
+            </a:pPr>
+            <a:r>
+              <a:rPr lang="en-US" sz="1100" dirty="0">
+                <a:solidFill>
+                  <a:schemeClr val="accent6"/>
+                </a:solidFill>
+              </a:rPr>
+              <a:t>Facts checked by keyword, judgement checked by an LLM judge. The leak (one customer's session reading another's payments) now has a regression test.</a:t>
+            </a:r>
+            <a:endParaRPr lang="en-US" sz="1100" dirty="0"/>
+          </a:p>
+        </p:txBody>
+      </p:sp>
+      <p:sp>
+        <p:nvSpPr>
+          <p:cNvPr id="25" name="Slide Number Placeholder 0"/>
+          <p:cNvSpPr>
+            <a:spLocks noGrp="1"/>
+          </p:cNvSpPr>
+          <p:nvPr>
+            <p:ph type="sldNum" sz="quarter" idx="4294967295"/>
+          </p:nvPr>
+        </p:nvSpPr>
+        <p:spPr>
+          <a:xfrm>
+            <a:off x="11247120" y="6400800"/>
+            <a:ext cx="457200" cy="274320"/>
+          </a:xfrm>
+          <a:prstGeom prst="rect">
+            <a:avLst/>
+          </a:prstGeom>
+          <a:extLst>
+            <a:ext uri="{C572A759-6A51-4108-AA02-DFA0A04FC94B}">
+              <ma14:wrappingTextBoxFlag xmlns:ma14="http://schemas.microsoft.com/office/mac/drawingml/2011/main" val="0"/>
+            </a:ext>
+          </a:extLst>
+        </p:spPr>
+        <p:txBody>
+          <a:bodyPr/>
+          <a:lstStyle>
+            <a:lvl1pPr>
+              <a:defRPr sz="1000">
+                <a:solidFill>
+                  <a:schemeClr val="accent6"/>
+                </a:solidFill>
+              </a:defRPr>
+            </a:lvl1pPr>
+          </a:lstStyle>
+          <a:p>
+            <a:pPr algn="r"/>
+            <a:fld id="{F7021451-1387-4CA6-816F-3879F97B5CBC}" type="slidenum">
+              <a:rPr b="0" lang="en-US"/>
+              <a:t>2</a:t>
+            </a:fld>
+            <a:endParaRPr lang="en-US"/>
+          </a:p>
+        </p:txBody>
+      </p:sp>
+    </p:spTree>
+  </p:cSld>
+  <p:clrMapOvr>
+    <a:masterClrMapping/>
+  </p:clrMapOvr>
+</p:sld>
+</file>
+
+<file path=ppt/slides/slide16.xml><?xml version="1.0" encoding="utf-8"?>
 <p:sld xmlns:a="http://schemas.openxmlformats.org/drawingml/2006/main" xmlns:r="http://schemas.openxmlformats.org/officeDocument/2006/relationships" xmlns:p="http://schemas.openxmlformats.org/presentationml/2006/main">
   <p:cSld name="Slide 14">
     <p:spTree>
@@ -7411,7 +8550,7 @@
                 <a:ea typeface="Cambria" pitchFamily="34" charset="-122"/>
                 <a:cs typeface="Cambria" pitchFamily="34" charset="-120"/>
               </a:rPr>
-              <a:t>24</a:t>
+              <a:t>25</a:t>
             </a:r>
             <a:endParaRPr lang="en-US" sz="5400" dirty="0"/>
           </a:p>
@@ -7508,7 +8647,7 @@
                 <a:ea typeface="Cambria" pitchFamily="34" charset="-122"/>
                 <a:cs typeface="Cambria" pitchFamily="34" charset="-120"/>
               </a:rPr>
-              <a:t>115</a:t>
+              <a:t>148</a:t>
             </a:r>
             <a:endParaRPr lang="en-US" sz="5400" dirty="0"/>
           </a:p>
@@ -7544,7 +8683,7 @@
                   <a:schemeClr val="tx1"/>
                 </a:solidFill>
               </a:rPr>
-              <a:t>automated tests</a:t>
+              <a:t>unit tests</a:t>
             </a:r>
             <a:endParaRPr lang="en-US" sz="1700" dirty="0"/>
           </a:p>
@@ -7605,7 +8744,7 @@
                 <a:ea typeface="Cambria" pitchFamily="34" charset="-122"/>
                 <a:cs typeface="Cambria" pitchFamily="34" charset="-120"/>
               </a:rPr>
-              <a:t>6</a:t>
+              <a:t>12</a:t>
             </a:r>
             <a:endParaRPr lang="en-US" sz="5400" dirty="0"/>
           </a:p>
@@ -7641,7 +8780,7 @@
                   <a:schemeClr val="tx1"/>
                 </a:solidFill>
               </a:rPr>
-              <a:t>test journeys</a:t>
+              <a:t>live AI evaluation runs</a:t>
             </a:r>
             <a:endParaRPr lang="en-US" sz="1700" dirty="0"/>
           </a:p>
@@ -7797,7 +8936,7 @@
 </p:sld>
 </file>
 
-<file path=ppt/slides/slide15.xml><?xml version="1.0" encoding="utf-8"?>
+<file path=ppt/slides/slide17.xml><?xml version="1.0" encoding="utf-8"?>
 <p:sld xmlns:a="http://schemas.openxmlformats.org/drawingml/2006/main" xmlns:r="http://schemas.openxmlformats.org/officeDocument/2006/relationships" xmlns:p="http://schemas.openxmlformats.org/presentationml/2006/main">
   <p:cSld name="Slide 15">
     <p:spTree>
@@ -8495,7 +9634,7 @@
 </p:sld>
 </file>
 
-<file path=ppt/slides/slide16.xml><?xml version="1.0" encoding="utf-8"?>
+<file path=ppt/slides/slide18.xml><?xml version="1.0" encoding="utf-8"?>
 <p:sld xmlns:a="http://schemas.openxmlformats.org/drawingml/2006/main" xmlns:r="http://schemas.openxmlformats.org/officeDocument/2006/relationships" xmlns:p="http://schemas.openxmlformats.org/presentationml/2006/main">
   <p:cSld name="Slide 16">
     <p:spTree>
@@ -9302,7 +10441,7 @@
 </p:sld>
 </file>
 
-<file path=ppt/slides/slide17.xml><?xml version="1.0" encoding="utf-8"?>
+<file path=ppt/slides/slide19.xml><?xml version="1.0" encoding="utf-8"?>
 <p:sld xmlns:a="http://schemas.openxmlformats.org/drawingml/2006/main" xmlns:r="http://schemas.openxmlformats.org/officeDocument/2006/relationships" xmlns:p="http://schemas.openxmlformats.org/presentationml/2006/main">
   <p:cSld name="Slide 17">
     <p:spTree>
@@ -9389,7 +10528,7 @@
                   <a:schemeClr val="accent4"/>
                 </a:solidFill>
               </a:rPr>
-              <a:t>Live demo in nsflow: hackathon/house_move</a:t>
+              <a:t>Live demo: the House Move app and nsflow</a:t>
             </a:r>
             <a:endParaRPr lang="en-US" sz="2200" dirty="0"/>
           </a:p>
@@ -10481,7 +11620,7 @@
                   <a:schemeClr val="tx1"/>
                 </a:solidFill>
               </a:rPr>
-              <a:t>Read and approve each draft in your portal, or with a code in the chat</a:t>
+              <a:t>Approve all, or approve, change or skip each, in the app or the chat</a:t>
             </a:r>
             <a:endParaRPr lang="en-US" sz="1400" dirty="0"/>
           </a:p>
@@ -10597,7 +11736,7 @@
                   <a:schemeClr val="tx1"/>
                 </a:solidFill>
               </a:rPr>
-              <a:t>Sends, replies and replans when the date moves</a:t>
+              <a:t>Sends, replans, and hands you ready-made packs</a:t>
             </a:r>
             <a:endParaRPr lang="en-US" sz="1400" dirty="0"/>
           </a:p>
@@ -11318,7 +12457,7 @@
                   <a:schemeClr val="tx1"/>
                 </a:solidFill>
               </a:rPr>
-              <a:t>Resume any time with a case reference; delete on request</a:t>
+              <a:t>Come back with your case reference and a resume code; delete on request</a:t>
             </a:r>
             <a:endParaRPr lang="en-US" sz="1700" dirty="0"/>
           </a:p>
@@ -12204,7 +13343,7 @@
                   <a:schemeClr val="tx2"/>
                 </a:solidFill>
               </a:rPr>
-              <a:t>Demo customer: 12 providers found, including the forgotten pet insurance. Anything below 70% confidence is asked, not assumed.</a:t>
+              <a:t>Demo customer: 14 organisations found, including the forgotten pet insurance and a credit card. Anything below 70% confidence is asked, not assumed.</a:t>
             </a:r>
             <a:endParaRPr lang="en-US" sz="1600" dirty="0"/>
           </a:p>
@@ -12786,7 +13925,7 @@
                   <a:schemeClr val="tx1"/>
                 </a:solidFill>
               </a:rPr>
-              <a:t>Which obligations apply (24 rules, each with a source)</a:t>
+              <a:t>Which obligations apply (25 rules, each with a source)</a:t>
             </a:r>
             <a:endParaRPr lang="en-US" sz="1600" dirty="0"/>
           </a:p>

</xml_diff>